<commit_message>
feat: finalize StreetCart KC submission package
</commit_message>
<xml_diff>
--- a/docs/archive/legacy/2026-03-28-competition-package/plans/StreetCart_KC_Oracle.pptx
+++ b/docs/archive/legacy/2026-03-28-competition-package/plans/StreetCart_KC_Oracle.pptx
@@ -1951,7 +1951,7 @@
                 <a:ea typeface="Aptos" pitchFamily="34" charset="-122"/>
                 <a:cs typeface="Aptos" pitchFamily="34" charset="-120"/>
               </a:rPr>
-              <a:t>StreetCart KC uses the Kansas City streetcar corridor as the public-facing food-access spine, while partner hubs move food into priority ZIP codes and a verified volunteer bracket keeps the 60-day pilot visible.</a:t>
+              <a:t>StreetCart KC converts Kansas City's fare-free streetcar corridor into a gamified food access backbone, using sports-team volunteer tournaments to move grocery boxes from transit hubs into the city's worst food deserts for $20-35 per delivered box.</a:t>
             </a:r>
             <a:endParaRPr lang="en-US" sz="1300" dirty="0"/>
           </a:p>
@@ -2254,7 +2254,7 @@
                 <a:ea typeface="Aptos Display" pitchFamily="34" charset="-122"/>
                 <a:cs typeface="Aptos Display" pitchFamily="34" charset="-120"/>
               </a:rPr>
-              <a:t>3M lbs</a:t>
+              <a:t>46,400</a:t>
             </a:r>
             <a:endParaRPr lang="en-US" sz="2000" dirty="0"/>
           </a:p>
@@ -2293,7 +2293,7 @@
                 <a:ea typeface="Aptos" pitchFamily="34" charset="-122"/>
                 <a:cs typeface="Aptos" pitchFamily="34" charset="-120"/>
               </a:rPr>
-              <a:t>Federal supply shock</a:t>
+              <a:t>Residents hit by store closures</a:t>
             </a:r>
             <a:endParaRPr lang="en-US" sz="1000" dirty="0"/>
           </a:p>
@@ -2332,7 +2332,7 @@
                 <a:ea typeface="Aptos" pitchFamily="34" charset="-122"/>
                 <a:cs typeface="Aptos" pitchFamily="34" charset="-120"/>
               </a:rPr>
-              <a:t>Harvesters shortfall this quarter after a 40% TEFAP reduction.</a:t>
+              <a:t>Four grocery closures in 2024-2025 landed inside USDA food-desert ZIPs.</a:t>
             </a:r>
             <a:endParaRPr lang="en-US" sz="950" dirty="0"/>
           </a:p>
@@ -2398,7 +2398,7 @@
                 <a:ea typeface="Aptos Display" pitchFamily="34" charset="-122"/>
                 <a:cs typeface="Aptos Display" pitchFamily="34" charset="-120"/>
               </a:rPr>
-              <a:t>1 in 7</a:t>
+              <a:t>3M lbs</a:t>
             </a:r>
             <a:endParaRPr lang="en-US" sz="2000" dirty="0"/>
           </a:p>
@@ -2437,7 +2437,7 @@
                 <a:ea typeface="Aptos" pitchFamily="34" charset="-122"/>
                 <a:cs typeface="Aptos" pitchFamily="34" charset="-120"/>
               </a:rPr>
-              <a:t>Resident need</a:t>
+              <a:t>Federal supply shortfall</a:t>
             </a:r>
             <a:endParaRPr lang="en-US" sz="1000" dirty="0"/>
           </a:p>
@@ -2476,7 +2476,7 @@
                 <a:ea typeface="Aptos" pitchFamily="34" charset="-122"/>
                 <a:cs typeface="Aptos" pitchFamily="34" charset="-120"/>
               </a:rPr>
-              <a:t>Kansas Citians are food insecure at a 10-year high.</a:t>
+              <a:t>Harvesters reports a 3 million-pound quarterly gap after the TEFAP cut.</a:t>
             </a:r>
             <a:endParaRPr lang="en-US" sz="950" dirty="0"/>
           </a:p>
@@ -2542,7 +2542,7 @@
                 <a:ea typeface="Aptos Display" pitchFamily="34" charset="-122"/>
                 <a:cs typeface="Aptos Display" pitchFamily="34" charset="-120"/>
               </a:rPr>
-              <a:t>0 pantry hits</a:t>
+              <a:t>1,000 lbs</a:t>
             </a:r>
             <a:endParaRPr lang="en-US" sz="2000" dirty="0"/>
           </a:p>
@@ -2581,7 +2581,7 @@
                 <a:ea typeface="Aptos" pitchFamily="34" charset="-122"/>
                 <a:cs typeface="Aptos" pitchFamily="34" charset="-120"/>
               </a:rPr>
-              <a:t>Pantry gap</a:t>
+              <a:t>Produce rescue window</a:t>
             </a:r>
             <a:endParaRPr lang="en-US" sz="1000" dirty="0"/>
           </a:p>
@@ -2620,7 +2620,7 @@
                 <a:ea typeface="Aptos" pitchFamily="34" charset="-122"/>
                 <a:cs typeface="Aptos" pitchFamily="34" charset="-120"/>
               </a:rPr>
-              <a:t>Challenge API returned zero pantry results for ZIP 64130 despite high need.</a:t>
+              <a:t>Emergency tomatoes and peppers must be routed through cold-chain partners inside 48 hours.</a:t>
             </a:r>
             <a:endParaRPr lang="en-US" sz="950" dirty="0"/>
           </a:p>
@@ -3506,7 +3506,7 @@
                 <a:ea typeface="Aptos" pitchFamily="34" charset="-122"/>
                 <a:cs typeface="Aptos" pitchFamily="34" charset="-120"/>
               </a:rPr>
-              <a:t>Two problems. Two plans. Same architecture.</a:t>
+              <a:t>Two curveballs. Same operating spine.</a:t>
             </a:r>
             <a:endParaRPr lang="en-US" sz="1300" dirty="0"/>
           </a:p>
@@ -3542,7 +3542,7 @@
                   <a:srgbClr val="D7DDE8"/>
                 </a:solidFill>
               </a:rPr>
-              <a:t>StreetCart KC shifts outreach, partner routing, and volunteer dispatch without changing the streetcar-led, pickup-first, partner-supported pilot.</a:t>
+              <a:t>StreetCart KC handles the vote requirement and the 48-hour produce surge without changing the streetcar-backed, partner-led model.</a:t>
             </a:r>
             <a:endParaRPr lang="en-US" sz="1150" dirty="0"/>
           </a:p>
@@ -3605,7 +3605,7 @@
                   <a:srgbClr val="E3A23B"/>
                 </a:solidFill>
               </a:rPr>
-              <a:t>Community vote in 66101 + 66105</a:t>
+              <a:t>Voto y Verdura in 66101 + 66105</a:t>
             </a:r>
             <a:endParaRPr lang="en-US" sz="1600" dirty="0"/>
           </a:p>
@@ -3707,7 +3707,7 @@
                   <a:srgbClr val="D7DDE8"/>
                 </a:solidFill>
               </a:rPr>
-              <a:t>Use Spanish-first, trust-based outreach through El Centro Academy parents, Cross-Lines, Guadalupe Centers, and After the Harvest route touchpoints to turn resident support into proof of demand.</a:t>
+              <a:t>Spanish-first, trust-based outreach runs through El Centro Academy, Cross-Lines, tiendas, laundromats, and produce pop-ups instead of downtown civic channels.</a:t>
             </a:r>
             <a:endParaRPr lang="en-US" sz="1000" dirty="0"/>
           </a:p>
@@ -3801,7 +3801,7 @@
                 <a:ea typeface="Aptos" pitchFamily="34" charset="-122"/>
                 <a:cs typeface="Aptos" pitchFamily="34" charset="-120"/>
               </a:rPr>
-              <a:t>Cross-Lines Community Outreach</a:t>
+              <a:t>Cross-Lines distribution windows</a:t>
             </a:r>
             <a:endParaRPr lang="en-US" sz="880" dirty="0"/>
           </a:p>
@@ -3819,7 +3819,7 @@
                 <a:ea typeface="Aptos" pitchFamily="34" charset="-122"/>
                 <a:cs typeface="Aptos" pitchFamily="34" charset="-120"/>
               </a:rPr>
-              <a:t>Guadalupe Centers pantry hours</a:t>
+              <a:t>Minnesota Avenue bus stop pop-ups</a:t>
             </a:r>
             <a:endParaRPr lang="en-US" sz="880" dirty="0"/>
           </a:p>
@@ -3895,7 +3895,7 @@
                 <a:ea typeface="Aptos" pitchFamily="34" charset="-122"/>
                 <a:cs typeface="Aptos" pitchFamily="34" charset="-120"/>
               </a:rPr>
-              <a:t>Days 1-3: embed with trusted anchors, not downtown institutions</a:t>
+              <a:t>Days 1-3: collect support at trusted anchor sites</a:t>
             </a:r>
             <a:endParaRPr lang="en-US" sz="860" dirty="0"/>
           </a:p>
@@ -3913,7 +3913,7 @@
                 <a:ea typeface="Aptos" pitchFamily="34" charset="-122"/>
                 <a:cs typeface="Aptos" pitchFamily="34" charset="-120"/>
               </a:rPr>
-              <a:t>Days 4-10: run Voto y Verdura pop-ups with produce bags and support forms</a:t>
+              <a:t>Days 4-10: run produce giveaways with support forms in every bag</a:t>
             </a:r>
             <a:endParaRPr lang="en-US" sz="860" dirty="0"/>
           </a:p>
@@ -3931,7 +3931,7 @@
                 <a:ea typeface="Aptos" pitchFamily="34" charset="-122"/>
                 <a:cs typeface="Aptos" pitchFamily="34" charset="-120"/>
               </a:rPr>
-              <a:t>Days 11-13: canvass the densest blocks with bilingual two-person teams</a:t>
+              <a:t>Days 11-13: send bilingual two-person canvass teams into the densest blocks</a:t>
             </a:r>
             <a:endParaRPr lang="en-US" sz="860" dirty="0"/>
           </a:p>
@@ -4030,7 +4030,7 @@
                   <a:srgbClr val="FFFFFF"/>
                 </a:solidFill>
               </a:rPr>
-              <a:t>KCK Wildcats</a:t>
+              <a:t>KCK Unidos</a:t>
             </a:r>
             <a:endParaRPr lang="en-US" sz="840" dirty="0"/>
           </a:p>
@@ -4195,7 +4195,7 @@
                   <a:srgbClr val="0B1020"/>
                 </a:solidFill>
               </a:rPr>
-              <a:t>Cold storage is the binding constraint, so route produce to partners that can hold or move perishables immediately and treat the donation as a preseason scrimmage for volunteer dispatch.</a:t>
+              <a:t>Cold storage, not demand, is the binding constraint, so produce is routed to four partner sites that can hold or move perishables immediately.</a:t>
             </a:r>
             <a:endParaRPr lang="en-US" sz="980" dirty="0"/>
           </a:p>
@@ -4411,7 +4411,7 @@
                   <a:srgbClr val="73829B"/>
                 </a:solidFill>
               </a:rPr>
-              <a:t>Walk-in cooler on site</a:t>
+              <a:t>Walk-in cooler</a:t>
             </a:r>
             <a:endParaRPr lang="en-US" sz="810" dirty="0"/>
           </a:p>
@@ -4519,7 +4519,7 @@
                   <a:srgbClr val="73829B"/>
                 </a:solidFill>
               </a:rPr>
-              <a:t>Fridge, same-day or next-day turnover</a:t>
+              <a:t>Small fridge</a:t>
             </a:r>
             <a:endParaRPr lang="en-US" sz="810" dirty="0"/>
           </a:p>
@@ -4555,7 +4555,7 @@
                   <a:srgbClr val="0B1020"/>
                 </a:solidFill>
               </a:rPr>
-              <a:t>Della Lamb Community</a:t>
+              <a:t>Della Lamb</a:t>
             </a:r>
             <a:endParaRPr lang="en-US" sz="860" dirty="0"/>
           </a:p>
@@ -4627,7 +4627,7 @@
                   <a:srgbClr val="73829B"/>
                 </a:solidFill>
               </a:rPr>
-              <a:t>Fridge for short hold</a:t>
+              <a:t>Small fridge</a:t>
             </a:r>
             <a:endParaRPr lang="en-US" sz="810" dirty="0"/>
           </a:p>
@@ -4663,7 +4663,7 @@
                   <a:srgbClr val="0B1020"/>
                 </a:solidFill>
               </a:rPr>
-              <a:t>Harvesters Community Food Network</a:t>
+              <a:t>Harvesters</a:t>
             </a:r>
             <a:endParaRPr lang="en-US" sz="860" dirty="0"/>
           </a:p>
@@ -4735,7 +4735,7 @@
                   <a:srgbClr val="73829B"/>
                 </a:solidFill>
               </a:rPr>
-              <a:t>Industrial cold storage</a:t>
+              <a:t>Industrial</a:t>
             </a:r>
             <a:endParaRPr lang="en-US" sz="810" dirty="0"/>
           </a:p>
@@ -4807,7 +4807,7 @@
                   <a:srgbClr val="0B1020"/>
                 </a:solidFill>
               </a:rPr>
-              <a:t>Day 0: pick up, weigh, bag, and drop to cold-chain partners  •  Day 1: release same-day pop-up or partner distributions where space exists  •  Day 2: clear remaining stock through scheduled partner routes</a:t>
+              <a:t>Day 0: pick up, weigh, bag, and drop to cold-chain partners  •  Day 1: run same-day pop-up and partner distributions where cooler space exists  •  Day 2: clear the remaining inventory through scheduled partner routes</a:t>
             </a:r>
             <a:endParaRPr lang="en-US" sz="850" dirty="0"/>
           </a:p>
@@ -4870,7 +4870,7 @@
                   <a:srgbClr val="FFFFFF"/>
                 </a:solidFill>
               </a:rPr>
-              <a:t>The same decentralized, partner-based operating model handles resident trust and produce triage without changing the pilot thesis.</a:t>
+              <a:t>A decentralized partner network responds inside hours because the model relies on staging hubs, trusted agencies, and volunteers, not a single expensive building.</a:t>
             </a:r>
             <a:endParaRPr lang="en-US" sz="920" dirty="0"/>
           </a:p>
@@ -5427,7 +5427,7 @@
                 <a:ea typeface="Aptos Display" pitchFamily="34" charset="-122"/>
                 <a:cs typeface="Aptos Display" pitchFamily="34" charset="-120"/>
               </a:rPr>
-              <a:t>3M lbs</a:t>
+              <a:t>46,400</a:t>
             </a:r>
             <a:endParaRPr lang="en-US" sz="2800" dirty="0"/>
           </a:p>
@@ -5466,7 +5466,7 @@
                 <a:ea typeface="Aptos" pitchFamily="34" charset="-122"/>
                 <a:cs typeface="Aptos" pitchFamily="34" charset="-120"/>
               </a:rPr>
-              <a:t>Federal supply shock</a:t>
+              <a:t>Residents hit by store closures</a:t>
             </a:r>
             <a:endParaRPr lang="en-US" sz="1000" dirty="0"/>
           </a:p>
@@ -5505,7 +5505,7 @@
                 <a:ea typeface="Aptos" pitchFamily="34" charset="-122"/>
                 <a:cs typeface="Aptos" pitchFamily="34" charset="-120"/>
               </a:rPr>
-              <a:t>Harvesters shortfall this quarter after a 40% TEFAP reduction.</a:t>
+              <a:t>Four grocery closures in 2024-2025 landed inside USDA food-desert ZIPs.</a:t>
             </a:r>
             <a:endParaRPr lang="en-US" sz="950" dirty="0"/>
           </a:p>
@@ -5571,7 +5571,7 @@
                 <a:ea typeface="Aptos Display" pitchFamily="34" charset="-122"/>
                 <a:cs typeface="Aptos Display" pitchFamily="34" charset="-120"/>
               </a:rPr>
-              <a:t>1 in 7</a:t>
+              <a:t>3M lbs</a:t>
             </a:r>
             <a:endParaRPr lang="en-US" sz="2800" dirty="0"/>
           </a:p>
@@ -5610,7 +5610,7 @@
                 <a:ea typeface="Aptos" pitchFamily="34" charset="-122"/>
                 <a:cs typeface="Aptos" pitchFamily="34" charset="-120"/>
               </a:rPr>
-              <a:t>Resident need</a:t>
+              <a:t>Federal supply shortfall</a:t>
             </a:r>
             <a:endParaRPr lang="en-US" sz="1000" dirty="0"/>
           </a:p>
@@ -5649,7 +5649,7 @@
                 <a:ea typeface="Aptos" pitchFamily="34" charset="-122"/>
                 <a:cs typeface="Aptos" pitchFamily="34" charset="-120"/>
               </a:rPr>
-              <a:t>Kansas Citians are food insecure at a 10-year high.</a:t>
+              <a:t>Harvesters reports a 3 million-pound quarterly gap after the TEFAP cut.</a:t>
             </a:r>
             <a:endParaRPr lang="en-US" sz="950" dirty="0"/>
           </a:p>
@@ -5715,7 +5715,7 @@
                 <a:ea typeface="Aptos Display" pitchFamily="34" charset="-122"/>
                 <a:cs typeface="Aptos Display" pitchFamily="34" charset="-120"/>
               </a:rPr>
-              <a:t>0 pantry hits</a:t>
+              <a:t>1,000 lbs</a:t>
             </a:r>
             <a:endParaRPr lang="en-US" sz="2800" dirty="0"/>
           </a:p>
@@ -5754,7 +5754,7 @@
                 <a:ea typeface="Aptos" pitchFamily="34" charset="-122"/>
                 <a:cs typeface="Aptos" pitchFamily="34" charset="-120"/>
               </a:rPr>
-              <a:t>Pantry gap</a:t>
+              <a:t>Produce rescue window</a:t>
             </a:r>
             <a:endParaRPr lang="en-US" sz="1000" dirty="0"/>
           </a:p>
@@ -5793,7 +5793,7 @@
                 <a:ea typeface="Aptos" pitchFamily="34" charset="-122"/>
                 <a:cs typeface="Aptos" pitchFamily="34" charset="-120"/>
               </a:rPr>
-              <a:t>Challenge API returned zero pantry results for ZIP 64130 despite high need.</a:t>
+              <a:t>Emergency tomatoes and peppers must be routed through cold-chain partners inside 48 hours.</a:t>
             </a:r>
             <a:endParaRPr lang="en-US" sz="950" dirty="0"/>
           </a:p>
@@ -7530,7 +7530,7 @@
                   <a:srgbClr val="C53E37"/>
                 </a:solidFill>
               </a:rPr>
-              <a:t>64130  •  64127  •  66101  •  66105  •  64132</a:t>
+              <a:t>66101  •  64127  •  66105  •  64130  •  64128  •  64132</a:t>
             </a:r>
             <a:endParaRPr lang="en-US" sz="1100" dirty="0"/>
           </a:p>
@@ -7593,7 +7593,7 @@
                   <a:srgbClr val="0B1020"/>
                 </a:solidFill>
               </a:rPr>
-              <a:t>River Market Exchange Hub</a:t>
+              <a:t>River Market Hub</a:t>
             </a:r>
             <a:endParaRPr lang="en-US" sz="1200" dirty="0"/>
           </a:p>
@@ -7767,7 +7767,7 @@
                   <a:srgbClr val="0B1020"/>
                 </a:solidFill>
               </a:rPr>
-              <a:t>Serves 64127, 64130, 64132</a:t>
+              <a:t>Serves 64127, 64130</a:t>
             </a:r>
             <a:endParaRPr lang="en-US" sz="850" dirty="0"/>
           </a:p>
@@ -7830,7 +7830,7 @@
                   <a:srgbClr val="0B1020"/>
                 </a:solidFill>
               </a:rPr>
-              <a:t>Union Station Civic Hub</a:t>
+              <a:t>Union Station Hub</a:t>
             </a:r>
             <a:endParaRPr lang="en-US" sz="1200" dirty="0"/>
           </a:p>
@@ -7932,7 +7932,7 @@
                   <a:srgbClr val="C53E37"/>
                 </a:solidFill>
               </a:rPr>
-              <a:t>Wed / Fri · 3:30 PM - 6:30 PM</a:t>
+              <a:t>Tue / Thu · 4:00 PM - 6:00 PM</a:t>
             </a:r>
             <a:endParaRPr lang="en-US" sz="950" dirty="0"/>
           </a:p>
@@ -8067,7 +8067,7 @@
                   <a:srgbClr val="0B1020"/>
                 </a:solidFill>
               </a:rPr>
-              <a:t>Guadalupe Family Hub</a:t>
+              <a:t>Westport Hub</a:t>
             </a:r>
             <a:endParaRPr lang="en-US" sz="1200" dirty="0"/>
           </a:p>
@@ -8133,7 +8133,7 @@
                 <a:ea typeface="Aptos" pitchFamily="34" charset="-122"/>
                 <a:cs typeface="Aptos" pitchFamily="34" charset="-120"/>
               </a:rPr>
-              <a:t>Partner feeder</a:t>
+              <a:t>Streetcar spine</a:t>
             </a:r>
             <a:endParaRPr lang="en-US" sz="850" dirty="0"/>
           </a:p>
@@ -8169,7 +8169,7 @@
                   <a:srgbClr val="C53E37"/>
                 </a:solidFill>
               </a:rPr>
-              <a:t>Tue / Thu · 10:00 AM - 2:00 PM</a:t>
+              <a:t>Wed / Fri · 11:00 AM - 2:00 PM</a:t>
             </a:r>
             <a:endParaRPr lang="en-US" sz="950" dirty="0"/>
           </a:p>
@@ -8205,7 +8205,7 @@
                   <a:srgbClr val="73829B"/>
                 </a:solidFill>
               </a:rPr>
-              <a:t>Guadalupe Centers + After the Harvest KC</a:t>
+              <a:t>Guadalupe Centers + KC Community Gardens</a:t>
             </a:r>
             <a:endParaRPr lang="en-US" sz="850" dirty="0"/>
           </a:p>
@@ -8241,7 +8241,7 @@
                   <a:srgbClr val="0B1020"/>
                 </a:solidFill>
               </a:rPr>
-              <a:t>Serves 64127, 64130</a:t>
+              <a:t>Serves 64127, 64128, 64132</a:t>
             </a:r>
             <a:endParaRPr lang="en-US" sz="850" dirty="0"/>
           </a:p>
@@ -8442,7 +8442,7 @@
                   <a:srgbClr val="73829B"/>
                 </a:solidFill>
               </a:rPr>
-              <a:t>Cross-Lines Community Outreach + Guadalupe Centers</a:t>
+              <a:t>Cross-Lines + El Centro</a:t>
             </a:r>
             <a:endParaRPr lang="en-US" sz="850" dirty="0"/>
           </a:p>
@@ -9039,7 +9039,7 @@
                 <a:ea typeface="Aptos" pitchFamily="34" charset="-122"/>
                 <a:cs typeface="Aptos" pitchFamily="34" charset="-120"/>
               </a:rPr>
-              <a:t>Direct 60-day pilot operations</a:t>
+              <a:t>Pilot operations (60 days)</a:t>
             </a:r>
             <a:endParaRPr lang="en-US" sz="1000" dirty="0"/>
           </a:p>
@@ -9078,7 +9078,7 @@
                 <a:ea typeface="Aptos" pitchFamily="34" charset="-122"/>
                 <a:cs typeface="Aptos" pitchFamily="34" charset="-120"/>
               </a:rPr>
-              <a:t>30% of contract • Field staffing, partner stipends, food handling, SMS, volunteer ops.</a:t>
+              <a:t>30% of contract • Staff, food top-ups, cold-chain supplies, vans, insurance, gas cards, and contingency.</a:t>
             </a:r>
             <a:endParaRPr lang="en-US" sz="950" dirty="0"/>
           </a:p>
@@ -9144,7 +9144,7 @@
                 <a:ea typeface="Aptos Display" pitchFamily="34" charset="-122"/>
                 <a:cs typeface="Aptos Display" pitchFamily="34" charset="-120"/>
               </a:rPr>
-              <a:t>$110K</a:t>
+              <a:t>$120K</a:t>
             </a:r>
             <a:endParaRPr lang="en-US" sz="2200" dirty="0"/>
           </a:p>
@@ -9183,7 +9183,7 @@
                 <a:ea typeface="Aptos" pitchFamily="34" charset="-122"/>
                 <a:cs typeface="Aptos" pitchFamily="34" charset="-120"/>
               </a:rPr>
-              <a:t>Product and data platform</a:t>
+              <a:t>Tech build</a:t>
             </a:r>
             <a:endParaRPr lang="en-US" sz="1000" dirty="0"/>
           </a:p>
@@ -9222,7 +9222,7 @@
                 <a:ea typeface="Aptos" pitchFamily="34" charset="-122"/>
                 <a:cs typeface="Aptos" pitchFamily="34" charset="-120"/>
               </a:rPr>
-              <a:t>22% of contract • Operator dashboard, resident messaging flow, leaderboard, data integration.</a:t>
+              <a:t>24% of contract • Dispatch and gamification platform, kiosk integration, routing, dashboard, and QA.</a:t>
             </a:r>
             <a:endParaRPr lang="en-US" sz="950" dirty="0"/>
           </a:p>
@@ -9288,7 +9288,7 @@
                 <a:ea typeface="Aptos Display" pitchFamily="34" charset="-122"/>
                 <a:cs typeface="Aptos Display" pitchFamily="34" charset="-120"/>
               </a:rPr>
-              <a:t>$90K</a:t>
+              <a:t>$100K</a:t>
             </a:r>
             <a:endParaRPr lang="en-US" sz="2200" dirty="0"/>
           </a:p>
@@ -9327,7 +9327,7 @@
                 <a:ea typeface="Aptos" pitchFamily="34" charset="-122"/>
                 <a:cs typeface="Aptos" pitchFamily="34" charset="-120"/>
               </a:rPr>
-              <a:t>Partner activation and resident outreach</a:t>
+              <a:t>Marketing + branding</a:t>
             </a:r>
             <a:endParaRPr lang="en-US" sz="1000" dirty="0"/>
           </a:p>
@@ -9366,7 +9366,7 @@
                 <a:ea typeface="Aptos" pitchFamily="34" charset="-122"/>
                 <a:cs typeface="Aptos" pitchFamily="34" charset="-120"/>
               </a:rPr>
-              <a:t>18% of contract • Bilingual outreach, community liaisons, volunteer recruitment, event support.</a:t>
+              <a:t>20% of contract • Campaign creative, co-branding, launch events, PR, and bilingual outreach.</a:t>
             </a:r>
             <a:endParaRPr lang="en-US" sz="950" dirty="0"/>
           </a:p>
@@ -9432,7 +9432,7 @@
                 <a:ea typeface="Aptos Display" pitchFamily="34" charset="-122"/>
                 <a:cs typeface="Aptos Display" pitchFamily="34" charset="-120"/>
               </a:rPr>
-              <a:t>$55K</a:t>
+              <a:t>$80K</a:t>
             </a:r>
             <a:endParaRPr lang="en-US" sz="2200" dirty="0"/>
           </a:p>
@@ -9471,7 +9471,7 @@
                 <a:ea typeface="Aptos" pitchFamily="34" charset="-122"/>
                 <a:cs typeface="Aptos" pitchFamily="34" charset="-120"/>
               </a:rPr>
-              <a:t>Measurement and public proof</a:t>
+              <a:t>Streetcar wrap + renewal</a:t>
             </a:r>
             <a:endParaRPr lang="en-US" sz="1000" dirty="0"/>
           </a:p>
@@ -9510,7 +9510,7 @@
                 <a:ea typeface="Aptos" pitchFamily="34" charset="-122"/>
                 <a:cs typeface="Aptos" pitchFamily="34" charset="-120"/>
               </a:rPr>
-              <a:t>11% of contract • Impact reporting, city-ready scorecards, sponsorship packaging, wrap mock production.</a:t>
+              <a:t>16% of contract • Winning-team wrap, maintenance, and a seed runway into Season 2.</a:t>
             </a:r>
             <a:endParaRPr lang="en-US" sz="950" dirty="0"/>
           </a:p>
@@ -9576,7 +9576,7 @@
                 <a:ea typeface="Aptos Display" pitchFamily="34" charset="-122"/>
                 <a:cs typeface="Aptos Display" pitchFamily="34" charset="-120"/>
               </a:rPr>
-              <a:t>$95K</a:t>
+              <a:t>$50K</a:t>
             </a:r>
             <a:endParaRPr lang="en-US" sz="2200" dirty="0"/>
           </a:p>
@@ -9615,7 +9615,7 @@
                 <a:ea typeface="Aptos" pitchFamily="34" charset="-122"/>
                 <a:cs typeface="Aptos" pitchFamily="34" charset="-120"/>
               </a:rPr>
-              <a:t>Contingency and renewal runway</a:t>
+              <a:t>Evaluation</a:t>
             </a:r>
             <a:endParaRPr lang="en-US" sz="1000" dirty="0"/>
           </a:p>
@@ -9654,7 +9654,7 @@
                 <a:ea typeface="Aptos" pitchFamily="34" charset="-122"/>
                 <a:cs typeface="Aptos" pitchFamily="34" charset="-120"/>
               </a:rPr>
-              <a:t>19% of contract • Curveball reserve, scale-up cash, contract extension bridge.</a:t>
+              <a:t>10% of contract • Third-party evaluator, survey design, and the final report.</a:t>
             </a:r>
             <a:endParaRPr lang="en-US" sz="950" dirty="0"/>
           </a:p>
@@ -9947,7 +9947,7 @@
                 <a:ea typeface="Aptos Display" pitchFamily="34" charset="-122"/>
                 <a:cs typeface="Aptos Display" pitchFamily="34" charset="-120"/>
               </a:rPr>
-              <a:t>1,800+</a:t>
+              <a:t>3,000-5,000</a:t>
             </a:r>
             <a:endParaRPr lang="en-US" sz="2400" dirty="0"/>
           </a:p>
@@ -9986,7 +9986,7 @@
                 <a:ea typeface="Aptos" pitchFamily="34" charset="-122"/>
                 <a:cs typeface="Aptos" pitchFamily="34" charset="-120"/>
               </a:rPr>
-              <a:t>Unique households reached</a:t>
+              <a:t>Unique households served</a:t>
             </a:r>
             <a:endParaRPr lang="en-US" sz="1000" dirty="0"/>
           </a:p>
@@ -10025,7 +10025,7 @@
                 <a:ea typeface="Aptos" pitchFamily="34" charset="-122"/>
                 <a:cs typeface="Aptos" pitchFamily="34" charset="-120"/>
               </a:rPr>
-              <a:t>Priority ZIP households served during the 60-day pilot.</a:t>
+              <a:t>Households reached across the six highest-priority ZIPs during the 60-day pilot.</a:t>
             </a:r>
             <a:endParaRPr lang="en-US" sz="950" dirty="0"/>
           </a:p>
@@ -10091,7 +10091,7 @@
                 <a:ea typeface="Aptos Display" pitchFamily="34" charset="-122"/>
                 <a:cs typeface="Aptos Display" pitchFamily="34" charset="-120"/>
               </a:rPr>
-              <a:t>3,200+</a:t>
+              <a:t>5,000-7,500</a:t>
             </a:r>
             <a:endParaRPr lang="en-US" sz="2400" dirty="0"/>
           </a:p>
@@ -10130,7 +10130,7 @@
                 <a:ea typeface="Aptos" pitchFamily="34" charset="-122"/>
                 <a:cs typeface="Aptos" pitchFamily="34" charset="-120"/>
               </a:rPr>
-              <a:t>Completed service events</a:t>
+              <a:t>Total deliveries completed</a:t>
             </a:r>
             <a:endParaRPr lang="en-US" sz="1000" dirty="0"/>
           </a:p>
@@ -10169,7 +10169,7 @@
                 <a:ea typeface="Aptos" pitchFamily="34" charset="-122"/>
                 <a:cs typeface="Aptos" pitchFamily="34" charset="-120"/>
               </a:rPr>
-              <a:t>Verified pickups and deliveries across all hubs.</a:t>
+              <a:t>Verified boxes moved through hubs, routes, and selective delivery assists.</a:t>
             </a:r>
             <a:endParaRPr lang="en-US" sz="950" dirty="0"/>
           </a:p>
@@ -10235,7 +10235,7 @@
                 <a:ea typeface="Aptos Display" pitchFamily="34" charset="-122"/>
                 <a:cs typeface="Aptos Display" pitchFamily="34" charset="-120"/>
               </a:rPr>
-              <a:t>60,000 lbs</a:t>
+              <a:t>150K-250K</a:t>
             </a:r>
             <a:endParaRPr lang="en-US" sz="2400" dirty="0"/>
           </a:p>
@@ -10274,7 +10274,7 @@
                 <a:ea typeface="Aptos" pitchFamily="34" charset="-122"/>
                 <a:cs typeface="Aptos" pitchFamily="34" charset="-120"/>
               </a:rPr>
-              <a:t>Food moved</a:t>
+              <a:t>Pounds distributed</a:t>
             </a:r>
             <a:endParaRPr lang="en-US" sz="1000" dirty="0"/>
           </a:p>
@@ -10313,7 +10313,7 @@
                 <a:ea typeface="Aptos" pitchFamily="34" charset="-122"/>
                 <a:cs typeface="Aptos" pitchFamily="34" charset="-120"/>
               </a:rPr>
-              <a:t>Bundles and perishables moved before spoilage.</a:t>
+              <a:t>Combined donated and purchased food moved through partner-led operations.</a:t>
             </a:r>
             <a:endParaRPr lang="en-US" sz="950" dirty="0"/>
           </a:p>
@@ -10379,7 +10379,7 @@
                 <a:ea typeface="Aptos Display" pitchFamily="34" charset="-122"/>
                 <a:cs typeface="Aptos Display" pitchFamily="34" charset="-120"/>
               </a:rPr>
-              <a:t>50+</a:t>
+              <a:t>&gt;70%</a:t>
             </a:r>
             <a:endParaRPr lang="en-US" sz="2400" dirty="0"/>
           </a:p>
@@ -10418,7 +10418,7 @@
                 <a:ea typeface="Aptos" pitchFamily="34" charset="-122"/>
                 <a:cs typeface="Aptos" pitchFamily="34" charset="-120"/>
               </a:rPr>
-              <a:t>Volunteer teams activated</a:t>
+              <a:t>Priority ZIP share</a:t>
             </a:r>
             <a:endParaRPr lang="en-US" sz="1000" dirty="0"/>
           </a:p>
@@ -10457,7 +10457,7 @@
                 <a:ea typeface="Aptos" pitchFamily="34" charset="-122"/>
                 <a:cs typeface="Aptos" pitchFamily="34" charset="-120"/>
               </a:rPr>
-              <a:t>Schools, churches, fan groups, and employers in the bracket.</a:t>
+              <a:t>Delivery volume held in 64127, 64128, 64130, 64132, 66101, and 66105.</a:t>
             </a:r>
             <a:endParaRPr lang="en-US" sz="950" dirty="0"/>
           </a:p>
@@ -10560,7 +10560,7 @@
                 <a:ea typeface="Aptos" pitchFamily="34" charset="-122"/>
                 <a:cs typeface="Aptos" pitchFamily="34" charset="-120"/>
               </a:rPr>
-              <a:t>70%+ of volume delivered into the five target ZIP codes</a:t>
+              <a:t>3,000-5,000 households served with more than 70% of volume in the six worst ZIPs</a:t>
             </a:r>
             <a:endParaRPr lang="en-US" sz="1050" dirty="0"/>
           </a:p>
@@ -10578,7 +10578,7 @@
                 <a:ea typeface="Aptos" pitchFamily="34" charset="-122"/>
                 <a:cs typeface="Aptos" pitchFamily="34" charset="-120"/>
               </a:rPr>
-              <a:t>85%+ resident completion rate after SMS or partner outreach</a:t>
+              <a:t>Fully loaded delivered-box cost held below $35 with a 3:1 to 5:1 donated-food leverage ratio</a:t>
             </a:r>
             <a:endParaRPr lang="en-US" sz="1050" dirty="0"/>
           </a:p>
@@ -10596,7 +10596,7 @@
                 <a:ea typeface="Aptos" pitchFamily="34" charset="-122"/>
                 <a:cs typeface="Aptos" pitchFamily="34" charset="-120"/>
               </a:rPr>
-              <a:t>40%+ week-over-week volunteer team retention</a:t>
+              <a:t>Volunteer retention above 40% for repeat drivers and route claimers</a:t>
             </a:r>
             <a:endParaRPr lang="en-US" sz="1050" dirty="0"/>
           </a:p>
@@ -10614,7 +10614,7 @@
                 <a:ea typeface="Aptos" pitchFamily="34" charset="-122"/>
                 <a:cs typeface="Aptos" pitchFamily="34" charset="-120"/>
               </a:rPr>
-              <a:t>A public proof loop that city council can stand in front of and fund again</a:t>
+              <a:t>Community vote cleared in 66101 and 66105 inside 14 days</a:t>
             </a:r>
             <a:endParaRPr lang="en-US" sz="1050" dirty="0"/>
           </a:p>
@@ -11178,7 +11178,7 @@
                   <a:srgbClr val="E3A23B"/>
                 </a:solidFill>
               </a:rPr>
-              <a:t>248</a:t>
+              <a:t>1248</a:t>
             </a:r>
             <a:endParaRPr lang="en-US" sz="1100" dirty="0"/>
           </a:p>
@@ -11241,7 +11241,7 @@
                   <a:srgbClr val="FFFFFF"/>
                 </a:solidFill>
               </a:rPr>
-              <a:t>Royals Rally</a:t>
+              <a:t>Royals Respond</a:t>
             </a:r>
             <a:endParaRPr lang="en-US" sz="1000" dirty="0"/>
           </a:p>
@@ -11277,7 +11277,7 @@
                   <a:srgbClr val="E3A23B"/>
                 </a:solidFill>
               </a:rPr>
-              <a:t>233</a:t>
+              <a:t>1176</a:t>
             </a:r>
             <a:endParaRPr lang="en-US" sz="1100" dirty="0"/>
           </a:p>
@@ -11340,7 +11340,7 @@
                   <a:srgbClr val="FFFFFF"/>
                 </a:solidFill>
               </a:rPr>
-              <a:t>KU Jayhawk Service</a:t>
+              <a:t>Sporting KC</a:t>
             </a:r>
             <a:endParaRPr lang="en-US" sz="1000" dirty="0"/>
           </a:p>
@@ -11376,7 +11376,7 @@
                   <a:srgbClr val="E3A23B"/>
                 </a:solidFill>
               </a:rPr>
-              <a:t>214</a:t>
+              <a:t>1032</a:t>
             </a:r>
             <a:endParaRPr lang="en-US" sz="1100" dirty="0"/>
           </a:p>
@@ -11439,7 +11439,7 @@
                   <a:srgbClr val="FFFFFF"/>
                 </a:solidFill>
               </a:rPr>
-              <a:t>Church League South</a:t>
+              <a:t>KC Current</a:t>
             </a:r>
             <a:endParaRPr lang="en-US" sz="1000" dirty="0"/>
           </a:p>
@@ -11475,7 +11475,7 @@
                   <a:srgbClr val="E3A23B"/>
                 </a:solidFill>
               </a:rPr>
-              <a:t>196</a:t>
+              <a:t>984</a:t>
             </a:r>
             <a:endParaRPr lang="en-US" sz="1100" dirty="0"/>
           </a:p>
@@ -11760,7 +11760,7 @@
                   <a:srgbClr val="FFFFFF"/>
                 </a:solidFill>
               </a:rPr>
-              <a:t>Su próxima recogida de StreetCart KC</a:t>
+              <a:t>Su proxima recogida de StreetCart KC</a:t>
             </a:r>
             <a:endParaRPr lang="en-US" sz="1300" dirty="0"/>
           </a:p>
@@ -11796,7 +11796,7 @@
                   <a:srgbClr val="D7DDE8"/>
                 </a:solidFill>
               </a:rPr>
-              <a:t>Miércoles · 11:00 AM a 2:00 PM · Cross-Lines Connector Hub. Lleve una bolsa reutilizable. No se requiere identificación. El Centro tendrá apoyo en español en el sitio.</a:t>
+              <a:t>Miercoles · 11:00 AM a 2:00 PM · Cross-Lines Connector Hub. Lleve una bolsa reutilizable. No se requiere identificacion. El Centro tendra apoyo en espanol en el sitio.</a:t>
             </a:r>
             <a:endParaRPr lang="en-US" sz="1000" dirty="0"/>
           </a:p>
@@ -12362,7 +12362,7 @@
                   <a:srgbClr val="0B1020"/>
                 </a:solidFill>
               </a:rPr>
-              <a:t>64130</a:t>
+              <a:t>66101</a:t>
             </a:r>
             <a:endParaRPr lang="en-US" sz="850" dirty="0"/>
           </a:p>
@@ -12578,7 +12578,7 @@
                   <a:srgbClr val="0B1020"/>
                 </a:solidFill>
               </a:rPr>
-              <a:t>66101</a:t>
+              <a:t>66105</a:t>
             </a:r>
             <a:endParaRPr lang="en-US" sz="850" dirty="0"/>
           </a:p>
@@ -12650,7 +12650,7 @@
                   <a:srgbClr val="0B1020"/>
                 </a:solidFill>
               </a:rPr>
-              <a:t>Guadalupe</a:t>
+              <a:t>Westport</a:t>
             </a:r>
             <a:endParaRPr lang="en-US" sz="850" dirty="0"/>
           </a:p>
@@ -13190,7 +13190,7 @@
                   <a:srgbClr val="C53E37"/>
                 </a:solidFill>
               </a:rPr>
-              <a:t>248</a:t>
+              <a:t>1248</a:t>
             </a:r>
             <a:endParaRPr lang="en-US" sz="850" dirty="0"/>
           </a:p>
@@ -13226,7 +13226,7 @@
                   <a:srgbClr val="0B1020"/>
                 </a:solidFill>
               </a:rPr>
-              <a:t>Royals Rally</a:t>
+              <a:t>Royals Respond</a:t>
             </a:r>
             <a:endParaRPr lang="en-US" sz="850" dirty="0"/>
           </a:p>
@@ -13262,7 +13262,7 @@
                   <a:srgbClr val="C53E37"/>
                 </a:solidFill>
               </a:rPr>
-              <a:t>233</a:t>
+              <a:t>1176</a:t>
             </a:r>
             <a:endParaRPr lang="en-US" sz="850" dirty="0"/>
           </a:p>
@@ -13298,7 +13298,7 @@
                   <a:srgbClr val="0B1020"/>
                 </a:solidFill>
               </a:rPr>
-              <a:t>KU Jayhawk Service</a:t>
+              <a:t>Sporting KC</a:t>
             </a:r>
             <a:endParaRPr lang="en-US" sz="850" dirty="0"/>
           </a:p>
@@ -13334,7 +13334,7 @@
                   <a:srgbClr val="C53E37"/>
                 </a:solidFill>
               </a:rPr>
-              <a:t>214</a:t>
+              <a:t>1032</a:t>
             </a:r>
             <a:endParaRPr lang="en-US" sz="850" dirty="0"/>
           </a:p>
@@ -13664,7 +13664,7 @@
                 <a:ea typeface="Aptos" pitchFamily="34" charset="-122"/>
                 <a:cs typeface="Aptos" pitchFamily="34" charset="-120"/>
               </a:rPr>
-              <a:t>Challenge API evaluation narrowed the product inputs to harvest, pantries, supply alerts, and demographics.</a:t>
+              <a:t>Eight challenge endpoints were reduced to one operating fact base: alerts, demographics, harvest routes, closures, pantries, transit, scoreboards, and budget.</a:t>
             </a:r>
             <a:endParaRPr lang="en-US" sz="1100" dirty="0"/>
           </a:p>
@@ -13682,7 +13682,7 @@
                 <a:ea typeface="Aptos" pitchFamily="34" charset="-122"/>
                 <a:cs typeface="Aptos" pitchFamily="34" charset="-120"/>
               </a:rPr>
-              <a:t>Concept iteration pressure-tested streetcar vs. bus and locked the streetcar as the civic spine with bus as phase-two reach.</a:t>
+              <a:t>Curveballs were absorbed into the same model instead of being bolted on as side memos or appendix slides.</a:t>
             </a:r>
             <a:endParaRPr lang="en-US" sz="1100" dirty="0"/>
           </a:p>
@@ -13700,7 +13700,7 @@
                 <a:ea typeface="Aptos" pitchFamily="34" charset="-122"/>
                 <a:cs typeface="Aptos" pitchFamily="34" charset="-120"/>
               </a:rPr>
-              <a:t>Deck, Muse brief, and thin live site were kept on one fact base so judges can inspect the same pilot three different ways.</a:t>
+              <a:t>Oracle, Muse, and Architect now all read from one data spine, which keeps the deck, dashboard, and static site consistent under deadline pressure.</a:t>
             </a:r>
             <a:endParaRPr lang="en-US" sz="1100" dirty="0"/>
           </a:p>

</xml_diff>